<commit_message>
Update: Set author to 'Jibu Mathew - Data Analyst Intern' in Day 7 final report and presentation
</commit_message>
<xml_diff>
--- a/day 7/reports/Bluestock_MF_Presentation.pptx
+++ b/day 7/reports/Bluestock_MF_Presentation.pptx
@@ -3193,7 +3193,7 @@
               </a:defRPr>
             </a:pPr>
             <a:r>
-              <a:t>Prepared by: Intern / Data Analyst</a:t>
+              <a:t>Prepared by: Jibu Mathew - Data Analyst Intern</a:t>
             </a:r>
             <a:br/>
             <a:r>
@@ -3252,6 +3252,136 @@
             </a:pPr>
             <a:r>
               <a:t>Dashboard Walkthrough II: Investor Analytics &amp; Trends</a:t>
+            </a:r>
+          </a:p>
+        </p:txBody>
+      </p:sp>
+      <p:pic>
+        <p:nvPicPr>
+          <p:cNvPr id="3" name="Picture 2" descr="page_3.png"/>
+          <p:cNvPicPr>
+            <a:picLocks noChangeAspect="1"/>
+          </p:cNvPicPr>
+          <p:nvPr/>
+        </p:nvPicPr>
+        <p:blipFill>
+          <a:blip r:embed="rId2"/>
+          <a:stretch>
+            <a:fillRect/>
+          </a:stretch>
+        </p:blipFill>
+        <p:spPr>
+          <a:xfrm>
+            <a:off x="457200" y="1645920"/>
+            <a:ext cx="5486400" cy="3474720"/>
+          </a:xfrm>
+          <a:prstGeom prst="rect">
+            <a:avLst/>
+          </a:prstGeom>
+        </p:spPr>
+      </p:pic>
+      <p:sp>
+        <p:nvSpPr>
+          <p:cNvPr id="4" name="TextBox 3"/>
+          <p:cNvSpPr txBox="1"/>
+          <p:nvPr/>
+        </p:nvSpPr>
+        <p:spPr>
+          <a:xfrm>
+            <a:off x="457200" y="5303520"/>
+            <a:ext cx="5486400" cy="1097280"/>
+          </a:xfrm>
+          <a:prstGeom prst="rect">
+            <a:avLst/>
+          </a:prstGeom>
+          <a:noFill/>
+        </p:spPr>
+        <p:txBody>
+          <a:bodyPr wrap="square">
+            <a:spAutoFit/>
+          </a:bodyPr>
+          <a:lstStyle/>
+          <a:p>
+            <a:pPr>
+              <a:defRPr sz="1300">
+                <a:solidFill>
+                  <a:srgbClr val="0F172A"/>
+                </a:solidFill>
+                <a:latin typeface="Arial"/>
+              </a:defRPr>
+            </a:pPr>
+            <a:r>
+              <a:t>&lt;b&gt;Page 3: Investor Analytics&lt;/b&gt;</a:t>
+            </a:r>
+          </a:p>
+          <a:p>
+            <a:r>
+              <a:t>Geographic bar charts showing transaction volumes by state, product split (SIP vs Lumpsum), and age distributions.</a:t>
+            </a:r>
+          </a:p>
+        </p:txBody>
+      </p:sp>
+      <p:pic>
+        <p:nvPicPr>
+          <p:cNvPr id="5" name="Picture 4" descr="page_4.png"/>
+          <p:cNvPicPr>
+            <a:picLocks noChangeAspect="1"/>
+          </p:cNvPicPr>
+          <p:nvPr/>
+        </p:nvPicPr>
+        <p:blipFill>
+          <a:blip r:embed="rId3"/>
+          <a:stretch>
+            <a:fillRect/>
+          </a:stretch>
+        </p:blipFill>
+        <p:spPr>
+          <a:xfrm>
+            <a:off x="6217920" y="1645920"/>
+            <a:ext cx="5486400" cy="3474720"/>
+          </a:xfrm>
+          <a:prstGeom prst="rect">
+            <a:avLst/>
+          </a:prstGeom>
+        </p:spPr>
+      </p:pic>
+      <p:sp>
+        <p:nvSpPr>
+          <p:cNvPr id="6" name="TextBox 5"/>
+          <p:cNvSpPr txBox="1"/>
+          <p:nvPr/>
+        </p:nvSpPr>
+        <p:spPr>
+          <a:xfrm>
+            <a:off x="6217920" y="5303520"/>
+            <a:ext cx="5486400" cy="1097280"/>
+          </a:xfrm>
+          <a:prstGeom prst="rect">
+            <a:avLst/>
+          </a:prstGeom>
+          <a:noFill/>
+        </p:spPr>
+        <p:txBody>
+          <a:bodyPr wrap="square">
+            <a:spAutoFit/>
+          </a:bodyPr>
+          <a:lstStyle/>
+          <a:p>
+            <a:pPr>
+              <a:defRPr sz="1300">
+                <a:solidFill>
+                  <a:srgbClr val="0F172A"/>
+                </a:solidFill>
+                <a:latin typeface="Arial"/>
+              </a:defRPr>
+            </a:pPr>
+            <a:r>
+              <a:t>&lt;b&gt;Page 4: SIP &amp; Market Trends&lt;/b&gt;</a:t>
+            </a:r>
+          </a:p>
+          <a:p>
+            <a:r>
+              <a:t>Visualizes the relationship between SIP inflows and Nifty 50 index levels, and category flow heatmaps.</a:t>
             </a:r>
           </a:p>
         </p:txBody>
@@ -5213,6 +5343,136 @@
             </a:pPr>
             <a:r>
               <a:t>Dashboard Walkthrough I: Industry Overview &amp; Performance</a:t>
+            </a:r>
+          </a:p>
+        </p:txBody>
+      </p:sp>
+      <p:pic>
+        <p:nvPicPr>
+          <p:cNvPr id="3" name="Picture 2" descr="page_1.png"/>
+          <p:cNvPicPr>
+            <a:picLocks noChangeAspect="1"/>
+          </p:cNvPicPr>
+          <p:nvPr/>
+        </p:nvPicPr>
+        <p:blipFill>
+          <a:blip r:embed="rId2"/>
+          <a:stretch>
+            <a:fillRect/>
+          </a:stretch>
+        </p:blipFill>
+        <p:spPr>
+          <a:xfrm>
+            <a:off x="457200" y="1645920"/>
+            <a:ext cx="5486400" cy="3474720"/>
+          </a:xfrm>
+          <a:prstGeom prst="rect">
+            <a:avLst/>
+          </a:prstGeom>
+        </p:spPr>
+      </p:pic>
+      <p:sp>
+        <p:nvSpPr>
+          <p:cNvPr id="4" name="TextBox 3"/>
+          <p:cNvSpPr txBox="1"/>
+          <p:nvPr/>
+        </p:nvSpPr>
+        <p:spPr>
+          <a:xfrm>
+            <a:off x="457200" y="5303520"/>
+            <a:ext cx="5486400" cy="1097280"/>
+          </a:xfrm>
+          <a:prstGeom prst="rect">
+            <a:avLst/>
+          </a:prstGeom>
+          <a:noFill/>
+        </p:spPr>
+        <p:txBody>
+          <a:bodyPr wrap="square">
+            <a:spAutoFit/>
+          </a:bodyPr>
+          <a:lstStyle/>
+          <a:p>
+            <a:pPr>
+              <a:defRPr sz="1300">
+                <a:solidFill>
+                  <a:srgbClr val="0F172A"/>
+                </a:solidFill>
+                <a:latin typeface="Arial"/>
+              </a:defRPr>
+            </a:pPr>
+            <a:r>
+              <a:t>&lt;b&gt;Page 1: Industry Overview&lt;/b&gt;</a:t>
+            </a:r>
+          </a:p>
+          <a:p>
+            <a:r>
+              <a:t>KPIs: Total AUM, monthly SIP inflows, and folio counts. Line charts show industry growth.</a:t>
+            </a:r>
+          </a:p>
+        </p:txBody>
+      </p:sp>
+      <p:pic>
+        <p:nvPicPr>
+          <p:cNvPr id="5" name="Picture 4" descr="page_2.png"/>
+          <p:cNvPicPr>
+            <a:picLocks noChangeAspect="1"/>
+          </p:cNvPicPr>
+          <p:nvPr/>
+        </p:nvPicPr>
+        <p:blipFill>
+          <a:blip r:embed="rId3"/>
+          <a:stretch>
+            <a:fillRect/>
+          </a:stretch>
+        </p:blipFill>
+        <p:spPr>
+          <a:xfrm>
+            <a:off x="6217920" y="1645920"/>
+            <a:ext cx="5486400" cy="3474720"/>
+          </a:xfrm>
+          <a:prstGeom prst="rect">
+            <a:avLst/>
+          </a:prstGeom>
+        </p:spPr>
+      </p:pic>
+      <p:sp>
+        <p:nvSpPr>
+          <p:cNvPr id="6" name="TextBox 5"/>
+          <p:cNvSpPr txBox="1"/>
+          <p:nvPr/>
+        </p:nvSpPr>
+        <p:spPr>
+          <a:xfrm>
+            <a:off x="6217920" y="5303520"/>
+            <a:ext cx="5486400" cy="1097280"/>
+          </a:xfrm>
+          <a:prstGeom prst="rect">
+            <a:avLst/>
+          </a:prstGeom>
+          <a:noFill/>
+        </p:spPr>
+        <p:txBody>
+          <a:bodyPr wrap="square">
+            <a:spAutoFit/>
+          </a:bodyPr>
+          <a:lstStyle/>
+          <a:p>
+            <a:pPr>
+              <a:defRPr sz="1300">
+                <a:solidFill>
+                  <a:srgbClr val="0F172A"/>
+                </a:solidFill>
+                <a:latin typeface="Arial"/>
+              </a:defRPr>
+            </a:pPr>
+            <a:r>
+              <a:t>&lt;b&gt;Page 2: Fund Performance&lt;/b&gt;</a:t>
+            </a:r>
+          </a:p>
+          <a:p>
+            <a:r>
+              <a:t>Scatter plot of Risk vs Return, and interactive filters for AMC, category, and plan.</a:t>
             </a:r>
           </a:p>
         </p:txBody>

</xml_diff>